<commit_message>
Slide sensitivitas: pindahkan kekokohan skenario ke bagian skenario (opsi A)
Co-Authored-By: Claude Opus 5.5 <noreply@anthropic.com>
Claude-Session: https://claude.ai/code/session_01RwTK1q8JkWDwXbpfgwmLot
</commit_message>
<xml_diff>
--- a/Slide - Analisis Sensitivitas (1 slide).pptx
+++ b/Slide - Analisis Sensitivitas (1 slide).pptx
@@ -1166,7 +1166,7 @@
           <a:lstStyle/>
           <a:p>
             <a:r>
-              <a:t>Analisis sensitivitas saya lakukan dengan tiga cara: mengubah tiap parameter plus-minus 10 persen satu per satu, menguji parameter asumsi pada seluruh rentang nilainya, dan mengecek apakah urutan skenario berubah pada tujuh kondisi. Hasilnya, parameter yang paling berpengaruh justru asumsi: tiga dari empat teratas, dengan laju penurunan dasar paling besar, 42 persen. Ketidakpastian terbesar ada pada rasio laju penurunan terhadap laju pertumbuhan, yang tadi juga tidak bisa ditentukan dari data saat kalibrasi. Tapi yang terpenting, pada ketujuh kondisi itu urutan skenario tidak berubah sama sekali. Jadi angka 2050 memang bisa bergeser, tetapi perbandingan antarskenario tetap bisa dipegang.</a:t>
+              <a:t>Analisis sensitivitas saya lakukan dengan dua cara: mengubah tiap parameter plus-minus 10 persen satu per satu, dan menguji parameter asumsi pada seluruh rentang nilainya. Hasilnya, parameter yang paling berpengaruh justru asumsi: tiga dari empat teratas, dengan laju penurunan dasar paling besar, 42 persen. Ketidakpastian terbesar ada pada rasio laju penurunan terhadap laju pertumbuhan, yang saat kalibrasi juga tidak bisa ditentukan dari data. Karena itu angka 2050 tidak saya baca sebagai ramalan pasti, dan perbandingan antarskenario nanti saya uji ulang dengan menggeser asumsi-asumsi ini. Catatan bila ditanya: untuk lahan terbangun, yang paling berpengaruh adalah laju konversi lahan, dengan lebar rentang 115,70 poin persen.</a:t>
             </a:r>
           </a:p>
         </p:txBody>
@@ -4557,7 +4557,7 @@
                 <a:cs typeface="Calibri (MS) Bold"/>
                 <a:sym typeface="Calibri (MS) Bold"/>
               </a:rPr>
-              <a:t>Angka 2050 bisa bergeser cukup besar, tetapi urutan skenario tetap sama</a:t>
+              <a:t>Parameter yang paling berpengaruh justru asumsi, bukan data</a:t>
             </a:r>
           </a:p>
         </p:txBody>
@@ -6611,7 +6611,7 @@
                 </a:solidFill>
                 <a:latin typeface="Calibri (MS)"/>
               </a:rPr>
-              <a:t>① tiap parameter diubah ±10%, satu per satu (32 parameter)   ② diuji pada seluruh rentang nilainya (17 kelompok)   ③ urutan skenario dicek pada 7 kondisi</a:t>
+              <a:t>① tiap parameter diubah ±10%, satu per satu (32 parameter)     ② parameter asumsi diuji pada seluruh rentang nilainya (17 kelompok)</a:t>
             </a:r>
           </a:p>
         </p:txBody>
@@ -7150,7 +7150,7 @@
                 </a:solidFill>
                 <a:latin typeface="Calibri (MS)"/>
               </a:rPr>
-              <a:t>Saat rasionya digeser 0,60–0,90, hasil wisatawan 2050 berbeda hingga 153,57 poin (69,65 poin bila LPE dihitung ulang).</a:t>
+              <a:t>Mengubah rasio ini (0,60–0,90) membuat hasil wisatawan 2050 bisa bergeser hingga 153,57 poin persen (69,65 poin persen bila laju pertumbuhan dihitung ulang).</a:t>
             </a:r>
           </a:p>
         </p:txBody>
@@ -7172,11 +7172,11 @@
             </a:avLst>
           </a:prstGeom>
           <a:solidFill>
-            <a:srgbClr val="C9F0D6"/>
+            <a:srgbClr val="EAF8FA"/>
           </a:solidFill>
           <a:ln w="12700">
             <a:solidFill>
-              <a:srgbClr val="9BD8AF"/>
+              <a:srgbClr val="CFE5E9"/>
             </a:solidFill>
           </a:ln>
           <a:effectLst/>
@@ -7207,11 +7207,11 @@
             <a:r>
               <a:rPr sz="1490" b="1" i="0">
                 <a:solidFill>
-                  <a:srgbClr val="1E7A43"/>
+                  <a:srgbClr val="0B5E6E"/>
                 </a:solidFill>
                 <a:latin typeface="Calibri (MS) Bold"/>
               </a:rPr>
-              <a:t>Urutan skenario tetap sama</a:t>
+              <a:t>Diuji lanjut pada skenario</a:t>
             </a:r>
           </a:p>
           <a:p>
@@ -7227,7 +7227,7 @@
                 </a:solidFill>
                 <a:latin typeface="Calibri (MS)"/>
               </a:rPr>
-              <a:t>Pada 7 kondisi (C0–C6), ketujuh indikator memberi urutan skenario yang sama persis.</a:t>
+              <a:t>Karena asumsi sangat berpengaruh, perbandingan antarskenario nanti diuji ulang dengan menggeser asumsi-asumsi ini.</a:t>
             </a:r>
           </a:p>
         </p:txBody>
@@ -7297,7 +7297,7 @@
                 </a:solidFill>
                 <a:latin typeface="Calibri (MS)"/>
               </a:rPr>
-              <a:t>Angka proyeksi 2050 tidak bisa dibaca sebagai ramalan pasti, tetapi perbandingan antarskenario tetap bisa dipegang.</a:t>
+              <a:t>Angka 2050 sangat bergantung pada asumsi, jadi tidak dibaca sebagai ramalan pasti.</a:t>
             </a:r>
           </a:p>
         </p:txBody>
@@ -7336,7 +7336,7 @@
                 </a:solidFill>
                 <a:latin typeface="Calibri (MS)"/>
               </a:rPr>
-              <a:t>Sumber: Buku Subbab 4.7 (Tabel 56–57, Gambar 51) dan uji kekokohan peringkat skenario (Tabel 63). Rincian rancangan pengujian di lampiran.</a:t>
+              <a:t>Sumber: Buku Subbab 4.7 (Tabel 56–57, Gambar 51). Rincian rancangan pengujian di lampiran.</a:t>
             </a:r>
           </a:p>
         </p:txBody>

</xml_diff>